<commit_message>
v0.8.0 - Modulo Analisis, botones de manual y guia, datos demo
</commit_message>
<xml_diff>
--- a/docs/capacitacion/guias-rapidas-pinturas-liz.pptx
+++ b/docs/capacitacion/guias-rapidas-pinturas-liz.pptx
@@ -112,32 +112,32 @@
   <p:extLst>
     <p:ext uri="{521415D9-36F7-43E2-AB2F-B90AF26B5E84}">
       <p14:sectionLst xmlns:p14="http://schemas.microsoft.com/office/powerpoint/2010/main">
-        <p14:section name="Socio y Desarrollador" id="{f4c889b7-1bdd-38a6-b71d-b8da48bb1f85}">
+        <p14:section name="Socio y Desarrollador" id="{ea7e6358-1eef-3477-c0e1-de52aee35929}">
           <p14:sldIdLst>
             <p14:sldId id="256"/>
           </p14:sldIdLst>
         </p14:section>
-        <p14:section name="Administración" id="{7696e9b8-e49f-e3ea-801b-cf1c2f65cf2c}">
+        <p14:section name="Administración" id="{33676a88-ed16-5390-819b-103e0448fb94}">
           <p14:sldIdLst>
             <p14:sldId id="257"/>
           </p14:sldIdLst>
         </p14:section>
-        <p14:section name="Vendedor" id="{b0341408-24e1-cf68-88d0-4ba8de581631}">
+        <p14:section name="Vendedor" id="{96249611-7ca7-2c48-052a-b7dbee3afc2b}">
           <p14:sldIdLst>
             <p14:sldId id="258"/>
           </p14:sldIdLst>
         </p14:section>
-        <p14:section name="Taller" id="{0f2b6bd3-2dad-dcfb-add2-128a3b1f8f3d}">
+        <p14:section name="Taller" id="{2dfb2aa8-9aa4-0d21-196c-c85d4f6f3c95}">
           <p14:sldIdLst>
             <p14:sldId id="259"/>
           </p14:sldIdLst>
         </p14:section>
-        <p14:section name="Despacho" id="{7d8454d5-2fb7-1b2f-45de-ce72052b7994}">
+        <p14:section name="Despacho" id="{ef7baf7f-748e-6d50-585c-91c2faf56c85}">
           <p14:sldIdLst>
             <p14:sldId id="260"/>
           </p14:sldIdLst>
         </p14:section>
-        <p14:section name="Laboratorio" id="{90336c3b-b3b4-dd23-ae52-96169589e878}">
+        <p14:section name="Laboratorio" id="{69f9734a-16fd-0f37-e87d-6a0c32ab39a9}">
           <p14:sldIdLst>
             <p14:sldId id="261"/>
           </p14:sldIdLst>
@@ -1214,7 +1214,7 @@
                   <a:schemeClr val="accent6"/>
                 </a:solidFill>
               </a:rPr>
-              <a:t>Pinturas Liz · Guía rápida · versión 0.7.0 · Más detalle: Mi cuenta → Manual de usuario</a:t>
+              <a:t>Pinturas Liz · Guía rápida · versión 0.8.0 · Más detalle: Mi cuenta → Manual de usuario</a:t>
             </a:r>
             <a:endParaRPr lang="en-US" sz="900" dirty="0"/>
           </a:p>
@@ -1779,7 +1779,7 @@
         <p:spPr>
           <a:xfrm>
             <a:off x="941832" y="2798064"/>
-            <a:ext cx="6163056" cy="603504"/>
+            <a:ext cx="6163056" cy="512064"/>
           </a:xfrm>
           <a:prstGeom prst="rect">
             <a:avLst/>
@@ -1834,7 +1834,7 @@
         </p:nvSpPr>
         <p:spPr>
           <a:xfrm>
-            <a:off x="457200" y="3438144"/>
+            <a:off x="457200" y="3346704"/>
             <a:ext cx="347472" cy="347472"/>
           </a:xfrm>
           <a:prstGeom prst="ellipse">
@@ -1859,7 +1859,7 @@
         </p:nvSpPr>
         <p:spPr>
           <a:xfrm>
-            <a:off x="457200" y="3438144"/>
+            <a:off x="457200" y="3346704"/>
             <a:ext cx="347472" cy="347472"/>
           </a:xfrm>
           <a:prstGeom prst="rect">
@@ -1895,8 +1895,8 @@
         </p:nvSpPr>
         <p:spPr>
           <a:xfrm>
-            <a:off x="941832" y="3401568"/>
-            <a:ext cx="6163056" cy="603504"/>
+            <a:off x="941832" y="3310128"/>
+            <a:ext cx="6163056" cy="512064"/>
           </a:xfrm>
           <a:prstGeom prst="rect">
             <a:avLst/>
@@ -1951,7 +1951,7 @@
         </p:nvSpPr>
         <p:spPr>
           <a:xfrm>
-            <a:off x="457200" y="4041648"/>
+            <a:off x="457200" y="3858768"/>
             <a:ext cx="347472" cy="347472"/>
           </a:xfrm>
           <a:prstGeom prst="ellipse">
@@ -1976,7 +1976,7 @@
         </p:nvSpPr>
         <p:spPr>
           <a:xfrm>
-            <a:off x="457200" y="4041648"/>
+            <a:off x="457200" y="3858768"/>
             <a:ext cx="347472" cy="347472"/>
           </a:xfrm>
           <a:prstGeom prst="rect">
@@ -2012,8 +2012,8 @@
         </p:nvSpPr>
         <p:spPr>
           <a:xfrm>
-            <a:off x="941832" y="4005072"/>
-            <a:ext cx="6163056" cy="603504"/>
+            <a:off x="941832" y="3822192"/>
+            <a:ext cx="6163056" cy="512064"/>
           </a:xfrm>
           <a:prstGeom prst="rect">
             <a:avLst/>
@@ -2068,7 +2068,7 @@
         </p:nvSpPr>
         <p:spPr>
           <a:xfrm>
-            <a:off x="457200" y="4645152"/>
+            <a:off x="457200" y="4370832"/>
             <a:ext cx="347472" cy="347472"/>
           </a:xfrm>
           <a:prstGeom prst="ellipse">
@@ -2093,7 +2093,7 @@
         </p:nvSpPr>
         <p:spPr>
           <a:xfrm>
-            <a:off x="457200" y="4645152"/>
+            <a:off x="457200" y="4370832"/>
             <a:ext cx="347472" cy="347472"/>
           </a:xfrm>
           <a:prstGeom prst="rect">
@@ -2129,8 +2129,8 @@
         </p:nvSpPr>
         <p:spPr>
           <a:xfrm>
-            <a:off x="941832" y="4608576"/>
-            <a:ext cx="6163056" cy="603504"/>
+            <a:off x="941832" y="4334256"/>
+            <a:ext cx="6163056" cy="512064"/>
           </a:xfrm>
           <a:prstGeom prst="rect">
             <a:avLst/>
@@ -2185,7 +2185,7 @@
         </p:nvSpPr>
         <p:spPr>
           <a:xfrm>
-            <a:off x="457200" y="5248656"/>
+            <a:off x="457200" y="4882896"/>
             <a:ext cx="347472" cy="347472"/>
           </a:xfrm>
           <a:prstGeom prst="ellipse">
@@ -2210,7 +2210,7 @@
         </p:nvSpPr>
         <p:spPr>
           <a:xfrm>
-            <a:off x="457200" y="5248656"/>
+            <a:off x="457200" y="4882896"/>
             <a:ext cx="347472" cy="347472"/>
           </a:xfrm>
           <a:prstGeom prst="rect">
@@ -2246,8 +2246,8 @@
         </p:nvSpPr>
         <p:spPr>
           <a:xfrm>
-            <a:off x="941832" y="5212080"/>
-            <a:ext cx="6163056" cy="603504"/>
+            <a:off x="941832" y="4846320"/>
+            <a:ext cx="6163056" cy="512064"/>
           </a:xfrm>
           <a:prstGeom prst="rect">
             <a:avLst/>
@@ -2302,7 +2302,7 @@
         </p:nvSpPr>
         <p:spPr>
           <a:xfrm>
-            <a:off x="457200" y="5852160"/>
+            <a:off x="457200" y="5394960"/>
             <a:ext cx="347472" cy="347472"/>
           </a:xfrm>
           <a:prstGeom prst="ellipse">
@@ -2327,7 +2327,7 @@
         </p:nvSpPr>
         <p:spPr>
           <a:xfrm>
-            <a:off x="457200" y="5852160"/>
+            <a:off x="457200" y="5394960"/>
             <a:ext cx="347472" cy="347472"/>
           </a:xfrm>
           <a:prstGeom prst="rect">
@@ -2363,8 +2363,8 @@
         </p:nvSpPr>
         <p:spPr>
           <a:xfrm>
-            <a:off x="941832" y="5815584"/>
-            <a:ext cx="6163056" cy="603504"/>
+            <a:off x="941832" y="5358384"/>
+            <a:ext cx="6163056" cy="512064"/>
           </a:xfrm>
           <a:prstGeom prst="rect">
             <a:avLst/>
@@ -2388,7 +2388,7 @@
                   <a:schemeClr val="tx2"/>
                 </a:solidFill>
               </a:rPr>
-              <a:t>Haz lo de Administración</a:t>
+              <a:t>Mira el Análisis</a:t>
             </a:r>
             <a:endParaRPr lang="en-US" sz="1300" dirty="0"/>
           </a:p>
@@ -2405,7 +2405,7 @@
                   <a:schemeClr val="tx1"/>
                 </a:solidFill>
               </a:rPr>
-              <a:t>Enviar al taller, revisión, precios, cobros y compras</a:t>
+              <a:t>Ventas, cobranzas, producción y almacén por período</a:t>
             </a:r>
             <a:endParaRPr lang="en-US" sz="1300" dirty="0"/>
           </a:p>
@@ -2419,7 +2419,7 @@
         </p:nvSpPr>
         <p:spPr>
           <a:xfrm>
-            <a:off x="457200" y="6455664"/>
+            <a:off x="457200" y="5907024"/>
             <a:ext cx="347472" cy="347472"/>
           </a:xfrm>
           <a:prstGeom prst="ellipse">
@@ -2444,7 +2444,7 @@
         </p:nvSpPr>
         <p:spPr>
           <a:xfrm>
-            <a:off x="457200" y="6455664"/>
+            <a:off x="457200" y="5907024"/>
             <a:ext cx="347472" cy="347472"/>
           </a:xfrm>
           <a:prstGeom prst="rect">
@@ -2480,8 +2480,8 @@
         </p:nvSpPr>
         <p:spPr>
           <a:xfrm>
-            <a:off x="941832" y="6419088"/>
-            <a:ext cx="6163056" cy="603504"/>
+            <a:off x="941832" y="5870448"/>
+            <a:ext cx="6163056" cy="512064"/>
           </a:xfrm>
           <a:prstGeom prst="rect">
             <a:avLst/>
@@ -2505,6 +2505,123 @@
                   <a:schemeClr val="tx2"/>
                 </a:solidFill>
               </a:rPr>
+              <a:t>Haz lo de Administración</a:t>
+            </a:r>
+            <a:endParaRPr lang="en-US" sz="1300" dirty="0"/>
+          </a:p>
+          <a:p>
+            <a:pPr indent="0" marL="0">
+              <a:spcAft>
+                <a:spcPts val="200"/>
+              </a:spcAft>
+              <a:buNone/>
+            </a:pPr>
+            <a:r>
+              <a:rPr lang="en-US" sz="1300" dirty="0">
+                <a:solidFill>
+                  <a:schemeClr val="tx1"/>
+                </a:solidFill>
+              </a:rPr>
+              <a:t>Enviar al taller, revisión, precios, cobros y compras</a:t>
+            </a:r>
+            <a:endParaRPr lang="en-US" sz="1300" dirty="0"/>
+          </a:p>
+        </p:txBody>
+      </p:sp>
+      <p:sp>
+        <p:nvSpPr>
+          <p:cNvPr id="28" name="Paso 8"/>
+          <p:cNvSpPr/>
+          <p:nvPr/>
+        </p:nvSpPr>
+        <p:spPr>
+          <a:xfrm>
+            <a:off x="457200" y="6419088"/>
+            <a:ext cx="347472" cy="347472"/>
+          </a:xfrm>
+          <a:prstGeom prst="ellipse">
+            <a:avLst/>
+          </a:prstGeom>
+          <a:solidFill>
+            <a:schemeClr val="accent2"/>
+          </a:solidFill>
+          <a:ln w="12700">
+            <a:solidFill>
+              <a:schemeClr val="accent2"/>
+            </a:solidFill>
+            <a:prstDash val="solid"/>
+          </a:ln>
+        </p:spPr>
+      </p:sp>
+      <p:sp>
+        <p:nvSpPr>
+          <p:cNvPr id="29" name="Número 8"/>
+          <p:cNvSpPr txBox="1"/>
+          <p:nvPr/>
+        </p:nvSpPr>
+        <p:spPr>
+          <a:xfrm>
+            <a:off x="457200" y="6419088"/>
+            <a:ext cx="347472" cy="347472"/>
+          </a:xfrm>
+          <a:prstGeom prst="rect">
+            <a:avLst/>
+          </a:prstGeom>
+          <a:noFill/>
+          <a:ln/>
+        </p:spPr>
+        <p:txBody>
+          <a:bodyPr wrap="square" lIns="0" tIns="0" rIns="0" bIns="0" rtlCol="0" anchor="ctr"/>
+          <a:lstStyle/>
+          <a:p>
+            <a:pPr algn="ctr" indent="0" marL="0">
+              <a:buNone/>
+            </a:pPr>
+            <a:r>
+              <a:rPr lang="en-US" sz="1300" b="1" dirty="0">
+                <a:solidFill>
+                  <a:schemeClr val="tx1"/>
+                </a:solidFill>
+              </a:rPr>
+              <a:t>8</a:t>
+            </a:r>
+            <a:endParaRPr lang="en-US" sz="1300" dirty="0"/>
+          </a:p>
+        </p:txBody>
+      </p:sp>
+      <p:sp>
+        <p:nvSpPr>
+          <p:cNvPr id="30" name="Texto paso 8"/>
+          <p:cNvSpPr txBox="1"/>
+          <p:nvPr/>
+        </p:nvSpPr>
+        <p:spPr>
+          <a:xfrm>
+            <a:off x="941832" y="6382512"/>
+            <a:ext cx="6163056" cy="512064"/>
+          </a:xfrm>
+          <a:prstGeom prst="rect">
+            <a:avLst/>
+          </a:prstGeom>
+          <a:noFill/>
+          <a:ln/>
+        </p:spPr>
+        <p:txBody>
+          <a:bodyPr wrap="square" lIns="0" tIns="0" rIns="0" bIns="0" rtlCol="0" anchor="t"/>
+          <a:lstStyle/>
+          <a:p>
+            <a:pPr indent="0" marL="0">
+              <a:spcAft>
+                <a:spcPts val="200"/>
+              </a:spcAft>
+              <a:buNone/>
+            </a:pPr>
+            <a:r>
+              <a:rPr lang="en-US" sz="1300" b="1" dirty="0">
+                <a:solidFill>
+                  <a:schemeClr val="tx2"/>
+                </a:solidFill>
+              </a:rPr>
               <a:t>Desarrollador: evalúa mejoras</a:t>
             </a:r>
             <a:endParaRPr lang="en-US" sz="1300" dirty="0"/>
@@ -2530,13 +2647,13 @@
       </p:sp>
       <p:sp>
         <p:nvSpPr>
-          <p:cNvPr id="28" name="Marco socio-alertas"/>
+          <p:cNvPr id="31" name="Marco socio-alertas"/>
           <p:cNvSpPr/>
           <p:nvPr/>
         </p:nvSpPr>
         <p:spPr>
           <a:xfrm>
-            <a:off x="466344" y="7159752"/>
+            <a:off x="466344" y="7031736"/>
             <a:ext cx="3273552" cy="2073402"/>
           </a:xfrm>
           <a:prstGeom prst="roundRect">
@@ -2564,7 +2681,7 @@
       </p:sp>
       <p:pic>
         <p:nvPicPr>
-          <p:cNvPr id="29" name="Captura socio-alertas" descr="Pantalla de la aplicación: socio alertas">    </p:cNvPr>
+          <p:cNvPr id="32" name="Captura socio-alertas" descr="Pantalla de la aplicación: socio alertas">    </p:cNvPr>
           <p:cNvPicPr>
             <a:picLocks noChangeAspect="1"/>
           </p:cNvPicPr>
@@ -2578,7 +2695,7 @@
         </p:blipFill>
         <p:spPr>
           <a:xfrm>
-            <a:off x="502920" y="7196328"/>
+            <a:off x="502920" y="7068312"/>
             <a:ext cx="3200400" cy="2000250"/>
           </a:xfrm>
           <a:prstGeom prst="rect">
@@ -2588,13 +2705,13 @@
       </p:pic>
       <p:sp>
         <p:nvSpPr>
-          <p:cNvPr id="30" name="Marco socio-usuarios"/>
+          <p:cNvPr id="33" name="Marco socio-usuarios"/>
           <p:cNvSpPr/>
           <p:nvPr/>
         </p:nvSpPr>
         <p:spPr>
           <a:xfrm>
-            <a:off x="3849624" y="7159752"/>
+            <a:off x="3849624" y="7031736"/>
             <a:ext cx="3273552" cy="2073402"/>
           </a:xfrm>
           <a:prstGeom prst="roundRect">
@@ -2622,7 +2739,7 @@
       </p:sp>
       <p:pic>
         <p:nvPicPr>
-          <p:cNvPr id="31" name="Captura socio-usuarios" descr="Pantalla de la aplicación: socio usuarios">    </p:cNvPr>
+          <p:cNvPr id="34" name="Captura socio-usuarios" descr="Pantalla de la aplicación: socio usuarios">    </p:cNvPr>
           <p:cNvPicPr>
             <a:picLocks noChangeAspect="1"/>
           </p:cNvPicPr>
@@ -2636,7 +2753,7 @@
         </p:blipFill>
         <p:spPr>
           <a:xfrm>
-            <a:off x="3886200" y="7196328"/>
+            <a:off x="3886200" y="7068312"/>
             <a:ext cx="3200400" cy="2000250"/>
           </a:xfrm>
           <a:prstGeom prst="rect">
@@ -2646,7 +2763,7 @@
       </p:pic>
       <p:sp>
         <p:nvSpPr>
-          <p:cNvPr id="32" name="Tarjeta No puedes"/>
+          <p:cNvPr id="35" name="Tarjeta No puedes"/>
           <p:cNvSpPr/>
           <p:nvPr/>
         </p:nvSpPr>
@@ -2673,7 +2790,7 @@
       </p:sp>
       <p:sp>
         <p:nvSpPr>
-          <p:cNvPr id="33" name="Texto No puedes"/>
+          <p:cNvPr id="36" name="Texto No puedes"/>
           <p:cNvSpPr txBox="1"/>
           <p:nvPr/>
         </p:nvSpPr>
@@ -2729,7 +2846,7 @@
       </p:sp>
       <p:sp>
         <p:nvSpPr>
-          <p:cNvPr id="34" name="Tarjeta Ayuda"/>
+          <p:cNvPr id="37" name="Tarjeta Ayuda"/>
           <p:cNvSpPr/>
           <p:nvPr/>
         </p:nvSpPr>
@@ -2756,7 +2873,7 @@
       </p:sp>
       <p:sp>
         <p:nvSpPr>
-          <p:cNvPr id="35" name="Texto Ayuda"/>
+          <p:cNvPr id="38" name="Texto Ayuda"/>
           <p:cNvSpPr txBox="1"/>
           <p:nvPr/>
         </p:nvSpPr>
@@ -2804,7 +2921,7 @@
                   <a:schemeClr val="tx1"/>
                 </a:solidFill>
               </a:rPr>
-              <a:t>Mi cuenta → Manual · Avisar un error · Sugerir una mejora · Cambiar contraseña</a:t>
+              <a:t>Mi cuenta → Manual (PDF) · Avisar un error · Sugerir una mejora · Cambiar contraseña</a:t>
             </a:r>
             <a:endParaRPr lang="en-US" sz="1200" dirty="0"/>
           </a:p>
@@ -3091,7 +3208,7 @@
         <p:spPr>
           <a:xfrm>
             <a:off x="941832" y="2798064"/>
-            <a:ext cx="6163056" cy="603504"/>
+            <a:ext cx="6163056" cy="512064"/>
           </a:xfrm>
           <a:prstGeom prst="rect">
             <a:avLst/>
@@ -3146,7 +3263,7 @@
         </p:nvSpPr>
         <p:spPr>
           <a:xfrm>
-            <a:off x="457200" y="3438144"/>
+            <a:off x="457200" y="3346704"/>
             <a:ext cx="347472" cy="347472"/>
           </a:xfrm>
           <a:prstGeom prst="ellipse">
@@ -3171,7 +3288,7 @@
         </p:nvSpPr>
         <p:spPr>
           <a:xfrm>
-            <a:off x="457200" y="3438144"/>
+            <a:off x="457200" y="3346704"/>
             <a:ext cx="347472" cy="347472"/>
           </a:xfrm>
           <a:prstGeom prst="rect">
@@ -3207,8 +3324,8 @@
         </p:nvSpPr>
         <p:spPr>
           <a:xfrm>
-            <a:off x="941832" y="3401568"/>
-            <a:ext cx="6163056" cy="603504"/>
+            <a:off x="941832" y="3310128"/>
+            <a:ext cx="6163056" cy="512064"/>
           </a:xfrm>
           <a:prstGeom prst="rect">
             <a:avLst/>
@@ -3263,7 +3380,7 @@
         </p:nvSpPr>
         <p:spPr>
           <a:xfrm>
-            <a:off x="457200" y="4041648"/>
+            <a:off x="457200" y="3858768"/>
             <a:ext cx="347472" cy="347472"/>
           </a:xfrm>
           <a:prstGeom prst="ellipse">
@@ -3288,7 +3405,7 @@
         </p:nvSpPr>
         <p:spPr>
           <a:xfrm>
-            <a:off x="457200" y="4041648"/>
+            <a:off x="457200" y="3858768"/>
             <a:ext cx="347472" cy="347472"/>
           </a:xfrm>
           <a:prstGeom prst="rect">
@@ -3324,8 +3441,8 @@
         </p:nvSpPr>
         <p:spPr>
           <a:xfrm>
-            <a:off x="941832" y="4005072"/>
-            <a:ext cx="6163056" cy="603504"/>
+            <a:off x="941832" y="3822192"/>
+            <a:ext cx="6163056" cy="512064"/>
           </a:xfrm>
           <a:prstGeom prst="rect">
             <a:avLst/>
@@ -3380,7 +3497,7 @@
         </p:nvSpPr>
         <p:spPr>
           <a:xfrm>
-            <a:off x="457200" y="4645152"/>
+            <a:off x="457200" y="4370832"/>
             <a:ext cx="347472" cy="347472"/>
           </a:xfrm>
           <a:prstGeom prst="ellipse">
@@ -3405,7 +3522,7 @@
         </p:nvSpPr>
         <p:spPr>
           <a:xfrm>
-            <a:off x="457200" y="4645152"/>
+            <a:off x="457200" y="4370832"/>
             <a:ext cx="347472" cy="347472"/>
           </a:xfrm>
           <a:prstGeom prst="rect">
@@ -3441,8 +3558,8 @@
         </p:nvSpPr>
         <p:spPr>
           <a:xfrm>
-            <a:off x="941832" y="4608576"/>
-            <a:ext cx="6163056" cy="603504"/>
+            <a:off x="941832" y="4334256"/>
+            <a:ext cx="6163056" cy="512064"/>
           </a:xfrm>
           <a:prstGeom prst="rect">
             <a:avLst/>
@@ -3497,7 +3614,7 @@
         </p:nvSpPr>
         <p:spPr>
           <a:xfrm>
-            <a:off x="457200" y="5248656"/>
+            <a:off x="457200" y="4882896"/>
             <a:ext cx="347472" cy="347472"/>
           </a:xfrm>
           <a:prstGeom prst="ellipse">
@@ -3522,7 +3639,7 @@
         </p:nvSpPr>
         <p:spPr>
           <a:xfrm>
-            <a:off x="457200" y="5248656"/>
+            <a:off x="457200" y="4882896"/>
             <a:ext cx="347472" cy="347472"/>
           </a:xfrm>
           <a:prstGeom prst="rect">
@@ -3558,8 +3675,8 @@
         </p:nvSpPr>
         <p:spPr>
           <a:xfrm>
-            <a:off x="941832" y="5212080"/>
-            <a:ext cx="6163056" cy="603504"/>
+            <a:off x="941832" y="4846320"/>
+            <a:ext cx="6163056" cy="512064"/>
           </a:xfrm>
           <a:prstGeom prst="rect">
             <a:avLst/>
@@ -3614,7 +3731,7 @@
         </p:nvSpPr>
         <p:spPr>
           <a:xfrm>
-            <a:off x="457200" y="5852160"/>
+            <a:off x="457200" y="5394960"/>
             <a:ext cx="347472" cy="347472"/>
           </a:xfrm>
           <a:prstGeom prst="ellipse">
@@ -3639,7 +3756,7 @@
         </p:nvSpPr>
         <p:spPr>
           <a:xfrm>
-            <a:off x="457200" y="5852160"/>
+            <a:off x="457200" y="5394960"/>
             <a:ext cx="347472" cy="347472"/>
           </a:xfrm>
           <a:prstGeom prst="rect">
@@ -3675,8 +3792,8 @@
         </p:nvSpPr>
         <p:spPr>
           <a:xfrm>
-            <a:off x="941832" y="5815584"/>
-            <a:ext cx="6163056" cy="603504"/>
+            <a:off x="941832" y="5358384"/>
+            <a:ext cx="6163056" cy="512064"/>
           </a:xfrm>
           <a:prstGeom prst="rect">
             <a:avLst/>
@@ -3731,7 +3848,7 @@
         </p:nvSpPr>
         <p:spPr>
           <a:xfrm>
-            <a:off x="457200" y="6455664"/>
+            <a:off x="457200" y="5907024"/>
             <a:ext cx="347472" cy="347472"/>
           </a:xfrm>
           <a:prstGeom prst="ellipse">
@@ -3756,7 +3873,7 @@
         </p:nvSpPr>
         <p:spPr>
           <a:xfrm>
-            <a:off x="457200" y="6455664"/>
+            <a:off x="457200" y="5907024"/>
             <a:ext cx="347472" cy="347472"/>
           </a:xfrm>
           <a:prstGeom prst="rect">
@@ -3792,8 +3909,8 @@
         </p:nvSpPr>
         <p:spPr>
           <a:xfrm>
-            <a:off x="941832" y="6419088"/>
-            <a:ext cx="6163056" cy="603504"/>
+            <a:off x="941832" y="5870448"/>
+            <a:ext cx="6163056" cy="512064"/>
           </a:xfrm>
           <a:prstGeom prst="rect">
             <a:avLst/>
@@ -3848,7 +3965,7 @@
         </p:nvSpPr>
         <p:spPr>
           <a:xfrm>
-            <a:off x="457200" y="7059168"/>
+            <a:off x="457200" y="6419088"/>
             <a:ext cx="347472" cy="347472"/>
           </a:xfrm>
           <a:prstGeom prst="ellipse">
@@ -3873,7 +3990,7 @@
         </p:nvSpPr>
         <p:spPr>
           <a:xfrm>
-            <a:off x="457200" y="7059168"/>
+            <a:off x="457200" y="6419088"/>
             <a:ext cx="347472" cy="347472"/>
           </a:xfrm>
           <a:prstGeom prst="rect">
@@ -3909,8 +4026,8 @@
         </p:nvSpPr>
         <p:spPr>
           <a:xfrm>
-            <a:off x="941832" y="7022592"/>
-            <a:ext cx="6163056" cy="603504"/>
+            <a:off x="941832" y="6382512"/>
+            <a:ext cx="6163056" cy="512064"/>
           </a:xfrm>
           <a:prstGeom prst="rect">
             <a:avLst/>
@@ -3959,18 +4076,135 @@
       </p:sp>
       <p:sp>
         <p:nvSpPr>
-          <p:cNvPr id="31" name="Marco adm-pedido-recibido"/>
+          <p:cNvPr id="31" name="Paso 9"/>
           <p:cNvSpPr/>
           <p:nvPr/>
         </p:nvSpPr>
         <p:spPr>
           <a:xfrm>
-            <a:off x="466344" y="7763256"/>
-            <a:ext cx="3273552" cy="2073402"/>
+            <a:off x="457200" y="6931152"/>
+            <a:ext cx="347472" cy="347472"/>
+          </a:xfrm>
+          <a:prstGeom prst="ellipse">
+            <a:avLst/>
+          </a:prstGeom>
+          <a:solidFill>
+            <a:schemeClr val="accent4"/>
+          </a:solidFill>
+          <a:ln w="12700">
+            <a:solidFill>
+              <a:schemeClr val="accent4"/>
+            </a:solidFill>
+            <a:prstDash val="solid"/>
+          </a:ln>
+        </p:spPr>
+      </p:sp>
+      <p:sp>
+        <p:nvSpPr>
+          <p:cNvPr id="32" name="Número 9"/>
+          <p:cNvSpPr txBox="1"/>
+          <p:nvPr/>
+        </p:nvSpPr>
+        <p:spPr>
+          <a:xfrm>
+            <a:off x="457200" y="6931152"/>
+            <a:ext cx="347472" cy="347472"/>
+          </a:xfrm>
+          <a:prstGeom prst="rect">
+            <a:avLst/>
+          </a:prstGeom>
+          <a:noFill/>
+          <a:ln/>
+        </p:spPr>
+        <p:txBody>
+          <a:bodyPr wrap="square" lIns="0" tIns="0" rIns="0" bIns="0" rtlCol="0" anchor="ctr"/>
+          <a:lstStyle/>
+          <a:p>
+            <a:pPr algn="ctr" indent="0" marL="0">
+              <a:buNone/>
+            </a:pPr>
+            <a:r>
+              <a:rPr lang="en-US" sz="1300" b="1" dirty="0">
+                <a:solidFill>
+                  <a:schemeClr val="bg1"/>
+                </a:solidFill>
+              </a:rPr>
+              <a:t>9</a:t>
+            </a:r>
+            <a:endParaRPr lang="en-US" sz="1300" dirty="0"/>
+          </a:p>
+        </p:txBody>
+      </p:sp>
+      <p:sp>
+        <p:nvSpPr>
+          <p:cNvPr id="33" name="Texto paso 9"/>
+          <p:cNvSpPr txBox="1"/>
+          <p:nvPr/>
+        </p:nvSpPr>
+        <p:spPr>
+          <a:xfrm>
+            <a:off x="941832" y="6894576"/>
+            <a:ext cx="6163056" cy="512064"/>
+          </a:xfrm>
+          <a:prstGeom prst="rect">
+            <a:avLst/>
+          </a:prstGeom>
+          <a:noFill/>
+          <a:ln/>
+        </p:spPr>
+        <p:txBody>
+          <a:bodyPr wrap="square" lIns="0" tIns="0" rIns="0" bIns="0" rtlCol="0" anchor="t"/>
+          <a:lstStyle/>
+          <a:p>
+            <a:pPr indent="0" marL="0">
+              <a:spcAft>
+                <a:spcPts val="200"/>
+              </a:spcAft>
+              <a:buNone/>
+            </a:pPr>
+            <a:r>
+              <a:rPr lang="en-US" sz="1300" b="1" dirty="0">
+                <a:solidFill>
+                  <a:schemeClr val="tx2"/>
+                </a:solidFill>
+              </a:rPr>
+              <a:t>Revisa el Análisis</a:t>
+            </a:r>
+            <a:endParaRPr lang="en-US" sz="1300" dirty="0"/>
+          </a:p>
+          <a:p>
+            <a:pPr indent="0" marL="0">
+              <a:spcAft>
+                <a:spcPts val="200"/>
+              </a:spcAft>
+              <a:buNone/>
+            </a:pPr>
+            <a:r>
+              <a:rPr lang="en-US" sz="1300" dirty="0">
+                <a:solidFill>
+                  <a:schemeClr val="tx1"/>
+                </a:solidFill>
+              </a:rPr>
+              <a:t>Deuda vencida por cliente y lo que hay que reponer</a:t>
+            </a:r>
+            <a:endParaRPr lang="en-US" sz="1300" dirty="0"/>
+          </a:p>
+        </p:txBody>
+      </p:sp>
+      <p:sp>
+        <p:nvSpPr>
+          <p:cNvPr id="34" name="Marco adm-pedido-recibido"/>
+          <p:cNvSpPr/>
+          <p:nvPr/>
+        </p:nvSpPr>
+        <p:spPr>
+          <a:xfrm>
+            <a:off x="466344" y="7543800"/>
+            <a:ext cx="2940710" cy="1865376"/>
           </a:xfrm>
           <a:prstGeom prst="roundRect">
             <a:avLst>
-              <a:gd name="adj" fmla="val 2646"/>
+              <a:gd name="adj" fmla="val 2941"/>
             </a:avLst>
           </a:prstGeom>
           <a:solidFill>
@@ -3993,7 +4227,7 @@
       </p:sp>
       <p:pic>
         <p:nvPicPr>
-          <p:cNvPr id="32" name="Captura adm-pedido-recibido" descr="Pantalla de la aplicación: adm pedido recibido">    </p:cNvPr>
+          <p:cNvPr id="35" name="Captura adm-pedido-recibido" descr="Pantalla de la aplicación: adm pedido recibido">    </p:cNvPr>
           <p:cNvPicPr>
             <a:picLocks noChangeAspect="1"/>
           </p:cNvPicPr>
@@ -4007,8 +4241,8 @@
         </p:blipFill>
         <p:spPr>
           <a:xfrm>
-            <a:off x="502920" y="7799832"/>
-            <a:ext cx="3200400" cy="2000250"/>
+            <a:off x="502920" y="7580376"/>
+            <a:ext cx="2867558" cy="1792224"/>
           </a:xfrm>
           <a:prstGeom prst="rect">
             <a:avLst/>
@@ -4017,18 +4251,18 @@
       </p:pic>
       <p:sp>
         <p:nvSpPr>
-          <p:cNvPr id="33" name="Marco adm-cobros-cuadre"/>
+          <p:cNvPr id="36" name="Marco adm-cobros-cuadre"/>
           <p:cNvSpPr/>
           <p:nvPr/>
         </p:nvSpPr>
         <p:spPr>
           <a:xfrm>
-            <a:off x="3849624" y="7763256"/>
-            <a:ext cx="3273552" cy="2073402"/>
+            <a:off x="3849624" y="7543800"/>
+            <a:ext cx="2940710" cy="1865376"/>
           </a:xfrm>
           <a:prstGeom prst="roundRect">
             <a:avLst>
-              <a:gd name="adj" fmla="val 2646"/>
+              <a:gd name="adj" fmla="val 2941"/>
             </a:avLst>
           </a:prstGeom>
           <a:solidFill>
@@ -4051,7 +4285,7 @@
       </p:sp>
       <p:pic>
         <p:nvPicPr>
-          <p:cNvPr id="34" name="Captura adm-cobros-cuadre" descr="Pantalla de la aplicación: adm cobros cuadre">    </p:cNvPr>
+          <p:cNvPr id="37" name="Captura adm-cobros-cuadre" descr="Pantalla de la aplicación: adm cobros cuadre">    </p:cNvPr>
           <p:cNvPicPr>
             <a:picLocks noChangeAspect="1"/>
           </p:cNvPicPr>
@@ -4065,8 +4299,8 @@
         </p:blipFill>
         <p:spPr>
           <a:xfrm>
-            <a:off x="3886200" y="7799832"/>
-            <a:ext cx="3200400" cy="2000250"/>
+            <a:off x="3886200" y="7580376"/>
+            <a:ext cx="2867558" cy="1792224"/>
           </a:xfrm>
           <a:prstGeom prst="rect">
             <a:avLst/>
@@ -4075,7 +4309,7 @@
       </p:pic>
       <p:sp>
         <p:nvSpPr>
-          <p:cNvPr id="35" name="Tarjeta No puedes"/>
+          <p:cNvPr id="38" name="Tarjeta No puedes"/>
           <p:cNvSpPr/>
           <p:nvPr/>
         </p:nvSpPr>
@@ -4102,7 +4336,7 @@
       </p:sp>
       <p:sp>
         <p:nvSpPr>
-          <p:cNvPr id="36" name="Texto No puedes"/>
+          <p:cNvPr id="39" name="Texto No puedes"/>
           <p:cNvSpPr txBox="1"/>
           <p:nvPr/>
         </p:nvSpPr>
@@ -4158,7 +4392,7 @@
       </p:sp>
       <p:sp>
         <p:nvSpPr>
-          <p:cNvPr id="37" name="Tarjeta Ayuda"/>
+          <p:cNvPr id="40" name="Tarjeta Ayuda"/>
           <p:cNvSpPr/>
           <p:nvPr/>
         </p:nvSpPr>
@@ -4185,7 +4419,7 @@
       </p:sp>
       <p:sp>
         <p:nvSpPr>
-          <p:cNvPr id="38" name="Texto Ayuda"/>
+          <p:cNvPr id="41" name="Texto Ayuda"/>
           <p:cNvSpPr txBox="1"/>
           <p:nvPr/>
         </p:nvSpPr>
@@ -4233,7 +4467,7 @@
                   <a:schemeClr val="tx1"/>
                 </a:solidFill>
               </a:rPr>
-              <a:t>Mi cuenta → Manual · Avisar un error · Sugerir una mejora · Cambiar contraseña</a:t>
+              <a:t>Mi cuenta → Manual (PDF) · Avisar un error · Sugerir una mejora · Cambiar contraseña</a:t>
             </a:r>
             <a:endParaRPr lang="en-US" sz="1200" dirty="0"/>
           </a:p>
@@ -5662,7 +5896,7 @@
                   <a:schemeClr val="tx1"/>
                 </a:solidFill>
               </a:rPr>
-              <a:t>Mi cuenta → Manual · Avisar un error · Sugerir una mejora · Cambiar contraseña</a:t>
+              <a:t>Mi cuenta → Manual (PDF) · Avisar un error · Sugerir una mejora · Cambiar contraseña</a:t>
             </a:r>
             <a:endParaRPr lang="en-US" sz="1200" dirty="0"/>
           </a:p>
@@ -6974,7 +7208,7 @@
                   <a:schemeClr val="tx1"/>
                 </a:solidFill>
               </a:rPr>
-              <a:t>Mi cuenta → Manual · Avisar un error · Sugerir una mejora · Cambiar contraseña</a:t>
+              <a:t>Mi cuenta → Manual (PDF) · Avisar un error · Sugerir una mejora · Cambiar contraseña</a:t>
             </a:r>
             <a:endParaRPr lang="en-US" sz="1200" dirty="0"/>
           </a:p>
@@ -8169,7 +8403,7 @@
                   <a:schemeClr val="tx1"/>
                 </a:solidFill>
               </a:rPr>
-              <a:t>Mi cuenta → Manual · Avisar un error · Sugerir una mejora · Cambiar contraseña</a:t>
+              <a:t>Mi cuenta → Manual (PDF) · Avisar un error · Sugerir una mejora · Cambiar contraseña</a:t>
             </a:r>
             <a:endParaRPr lang="en-US" sz="1200" dirty="0"/>
           </a:p>
@@ -9364,7 +9598,7 @@
                   <a:schemeClr val="tx1"/>
                 </a:solidFill>
               </a:rPr>
-              <a:t>Mi cuenta → Manual · Avisar un error · Sugerir una mejora · Cambiar contraseña</a:t>
+              <a:t>Mi cuenta → Manual (PDF) · Avisar un error · Sugerir una mejora · Cambiar contraseña</a:t>
             </a:r>
             <a:endParaRPr lang="en-US" sz="1200" dirty="0"/>
           </a:p>

</xml_diff>